<commit_message>
v10 final: apply four-persona review fixes (B/C hypothesis, re-apply measurements, scope premise)
Co-Authored-By: Claude Opus 5.5 <noreply@anthropic.com>
Claude-Session: https://claude.ai/code/session_01Qadxmh2cuTPoezLniB2znE
</commit_message>
<xml_diff>
--- a/학생자율연구II_연구계획발표/v10_논문요약형/학생자율연구II_연구계획발표_v10.pptx
+++ b/학생자율연구II_연구계획발표/v10_논문요약형/학생자율연구II_연구계획발표_v10.pptx
@@ -1697,7 +1697,7 @@
           </a:p>
           <a:p>
             <a:r>
-              <a:t>자동차 내비게이션은 터널처럼 GPS가 끊기는 구간에서도 관성 정보로 위치를 이어서 계산합니다. 하지만 가속도를 적분하는 방식이라 시간이 지날수록 오차가 쌓입니다. 하늘에서도 같은 문제를 풀어야 하는데, NASA의 화성 헬리콥터 인저뉴어티는 아래를 보는 카메라, IMU, 레이저 고도계를 결합해 GPS 없이 비행했습니다.</a:t>
+              <a:t>자동차 내비게이션은 터널처럼 GPS가 끊기는 구간에서도 관성 정보로 위치를 이어서 계산합니다. 하지만 가속도를 적분하는 방식이라 시간이 지날수록 오차가 쌓입니다. 하늘에서도 같은 문제를 풀어야 하는데, NASA의 화성 헬리콥터 인저뉴어티는 아래를 보는 카메라, IMU, 레이저 고도계를 결합해 위성항법이 없는 화성에서 비행했습니다.</a:t>
             </a:r>
           </a:p>
           <a:p>
@@ -2059,7 +2059,7 @@
           </a:p>
           <a:p>
             <a:r>
-              <a:t>(아래 흐름) 늦게 도착한 측정은 저장해 둔 이력에서 그 측정이 찍힌 시점의 상태를 꺼내 보정하고, 그 이후의 IMU 입력으로 현재까지 다시 계산합니다.</a:t>
+              <a:t>(아래 흐름) 늦게 도착한 측정은 저장해 둔 이력에서 그 측정이 찍힌 시점의 상태를 꺼내 보정하고, 그 이후의 IMU 입력과 그 사이에 들어온 측정을 다시 적용해 현재까지 계산합니다. 그래서 버퍼는 최대 지연보다 길게 잡습니다.</a:t>
             </a:r>
           </a:p>
         </p:txBody>
@@ -2391,7 +2391,7 @@
           </a:p>
           <a:p>
             <a:r>
-              <a:t>영상 처리는 파이썬 OpenCV로, 필터와 시간 처리는 매트랩으로 구현합니다. 추가 지연을 0에서 100 ms까지 바꿔 가며, 지연을 무시한 경우, PX4처럼 지연 시점에서 융합한 경우, 과거 상태를 재추정한 경우를 정답 궤적 대비 위치 오차와 처리시간으로 비교하겠습니다. 예상은 B와 C의 정확도는 비슷하지만, C는 현재 상태가 늦지 않는 대신 계산량이 늘어난다는 것이고, 이 차이를 숫자로 확인하는 것이 목표입니다.</a:t>
+              <a:t>영상 처리는 파이썬 OpenCV로, 필터와 시간 처리는 매트랩으로 구현합니다. 추가 지연을 0에서 100 ms까지 바꿔 가며, 지연을 무시한 경우, PX4처럼 지연 시점에서 융합한 경우, 과거 상태를 재추정한 경우를 정답 궤적 대비 위치 오차와 처리시간으로 비교하겠습니다. 세 방식 모두 현재 시각의 추정값을 정답과 비교합니다. 예상은 지연 시점에서의 정확도는 B와 C가 비슷하지만, B의 현재 값은 출력 예측기로 따라가는 근사이고 C는 보정 결과 그대로라는 차이가 있으며, 그 대신 C는 다시 계산하는 만큼 연산이 늘어난다는 것입니다. 이 차이를 숫자로 확인하는 것이 목표입니다.</a:t>
             </a:r>
           </a:p>
         </p:txBody>
@@ -7183,7 +7183,7 @@
                 <a:latin typeface="Arial"/>
                 <a:ea typeface="MS PGothic"/>
               </a:rPr>
-              <a:t>를 결합하여 GPS 없이 비행하였다. [2]</a:t>
+              <a:t>를 결합하여 위성항법이 없는 화성에서 비행하였다. [2]</a:t>
             </a:r>
           </a:p>
           <a:p>
@@ -8435,7 +8435,7 @@
                 <a:latin typeface="Arial"/>
                 <a:ea typeface="MS PGothic"/>
               </a:rPr>
-              <a:t>: 저장해 둔 이력에서 측정 시점의 상태를 꺼내 보정하고, 이후 IMU 입력으로 현재까지 다시 계산</a:t>
+              <a:t>: 저장해 둔 이력에서 측정 시점의 상태를 꺼내 보정하고, 이후 IMU 입력과 그 사이 측정을 다시 적용해 현재까지 재계산</a:t>
             </a:r>
           </a:p>
         </p:txBody>
@@ -8974,7 +8974,7 @@
                 <a:latin typeface="Arial"/>
                 <a:ea typeface="MS PGothic"/>
               </a:rPr>
-              <a:t>측정으로 보정</a:t>
+              <a:t>늦은 측정으로 보정</a:t>
             </a:r>
           </a:p>
         </p:txBody>
@@ -9054,7 +9054,7 @@
                 <a:latin typeface="Arial"/>
                 <a:ea typeface="MS PGothic"/>
               </a:rPr>
-              <a:t>현재까지 다시 계산</a:t>
+              <a:t>이후 입력·측정 재적용</a:t>
             </a:r>
           </a:p>
         </p:txBody>
@@ -9088,14 +9088,14 @@
               <a:buNone/>
             </a:pPr>
             <a:r>
-              <a:rPr sz="1050" b="0" i="0">
+              <a:rPr sz="1100" b="0" i="0">
                 <a:solidFill>
                   <a:srgbClr val="666666"/>
                 </a:solidFill>
                 <a:latin typeface="Arial"/>
                 <a:ea typeface="MS PGothic"/>
               </a:rPr>
-              <a:t>저장: 상태·공분산·IMU 입력·측정 이력</a:t>
+              <a:t>저장: 상태·공분산·IMU 입력·측정 이력 (버퍼 길이 ≥ 최대 지연)</a:t>
             </a:r>
           </a:p>
         </p:txBody>
@@ -10486,8 +10486,8 @@
         </p:nvSpPr>
         <p:spPr>
           <a:xfrm>
-            <a:off x="457200" y="1536192"/>
-            <a:ext cx="8229600" cy="4480560"/>
+            <a:off x="457200" y="1463040"/>
+            <a:ext cx="8229600" cy="4572000"/>
           </a:xfrm>
           <a:prstGeom prst="rect">
             <a:avLst/>
@@ -10513,7 +10513,7 @@
               <a:buNone/>
             </a:pPr>
             <a:r>
-              <a:rPr sz="1550" b="1" i="0">
+              <a:rPr sz="1500" b="1" i="0">
                 <a:solidFill>
                   <a:srgbClr val="1A1A1A"/>
                 </a:solidFill>
@@ -10536,7 +10536,7 @@
               <a:buChar char="•"/>
             </a:pPr>
             <a:r>
-              <a:rPr sz="1400" b="1" i="0">
+              <a:rPr sz="1350" b="1" i="0">
                 <a:solidFill>
                   <a:srgbClr val="1A1A1A"/>
                 </a:solidFill>
@@ -10546,7 +10546,7 @@
               <a:t>INSANE</a:t>
             </a:r>
             <a:r>
-              <a:rPr sz="1400" b="0" i="0">
+              <a:rPr sz="1350" b="0" i="0">
                 <a:solidFill>
                   <a:srgbClr val="333333"/>
                 </a:solidFill>
@@ -10556,7 +10556,7 @@
               <a:t> 실내 구간: 하향 카메라 20 Hz, 거리센서 30 Hz, IMU / 정답: </a:t>
             </a:r>
             <a:r>
-              <a:rPr sz="1400" b="1" i="0">
+              <a:rPr sz="1350" b="1" i="0">
                 <a:solidFill>
                   <a:srgbClr val="1A1A1A"/>
                 </a:solidFill>
@@ -10566,7 +10566,7 @@
               <a:t>모션캡처 궤적</a:t>
             </a:r>
             <a:r>
-              <a:rPr sz="1400" b="0" i="0">
+              <a:rPr sz="1350" b="0" i="0">
                 <a:solidFill>
                   <a:srgbClr val="333333"/>
                 </a:solidFill>
@@ -10589,7 +10589,7 @@
               <a:buChar char="•"/>
             </a:pPr>
             <a:r>
-              <a:rPr sz="1400" b="0" i="0">
+              <a:rPr sz="1350" b="0" i="0">
                 <a:solidFill>
                   <a:srgbClr val="333333"/>
                 </a:solidFill>
@@ -10599,7 +10599,7 @@
               <a:t>카메라 측정에 </a:t>
             </a:r>
             <a:r>
-              <a:rPr sz="1400" b="1" i="0">
+              <a:rPr sz="1350" b="1" i="0">
                 <a:solidFill>
                   <a:srgbClr val="1A1A1A"/>
                 </a:solidFill>
@@ -10609,7 +10609,7 @@
               <a:t>도착 시점 = 촬영 시점 + 실측 처리시간 + 추가 지연</a:t>
             </a:r>
             <a:r>
-              <a:rPr sz="1400" b="0" i="0">
+              <a:rPr sz="1350" b="0" i="0">
                 <a:solidFill>
                   <a:srgbClr val="333333"/>
                 </a:solidFill>
@@ -10619,7 +10619,7 @@
               <a:t>을 부여하고, </a:t>
             </a:r>
             <a:r>
-              <a:rPr sz="1400" b="1" i="0">
+              <a:rPr sz="1350" b="1" i="0">
                 <a:solidFill>
                   <a:srgbClr val="1A1A1A"/>
                 </a:solidFill>
@@ -10629,7 +10629,7 @@
               <a:t>도착 순서대로 재생</a:t>
             </a:r>
             <a:r>
-              <a:rPr sz="1400" b="0" i="0">
+              <a:rPr sz="1350" b="0" i="0">
                 <a:solidFill>
                   <a:srgbClr val="333333"/>
                 </a:solidFill>
@@ -10637,6 +10637,29 @@
                 <a:ea typeface="MS PGothic"/>
               </a:rPr>
               <a:t>하여 실시간 상황을 재현</a:t>
+            </a:r>
+          </a:p>
+          <a:p>
+            <a:pPr marL="274320" indent="-164592">
+              <a:lnSpc>
+                <a:spcPct val="115000"/>
+              </a:lnSpc>
+              <a:spcBef>
+                <a:spcPts val="400"/>
+              </a:spcBef>
+              <a:buSzPct val="100000"/>
+              <a:buFont typeface="MS PGothic"/>
+              <a:buChar char="•"/>
+            </a:pPr>
+            <a:r>
+              <a:rPr sz="1350" b="0" i="0">
+                <a:solidFill>
+                  <a:srgbClr val="333333"/>
+                </a:solidFill>
+                <a:latin typeface="Arial"/>
+                <a:ea typeface="MS PGothic"/>
+              </a:rPr>
+              <a:t>전제: 촬영 시각은 정확하다고 가정 (시간 오프셋 추정은 범위 밖)</a:t>
             </a:r>
           </a:p>
           <a:p>
@@ -10653,7 +10676,7 @@
               <a:buNone/>
             </a:pPr>
             <a:r>
-              <a:rPr sz="1550" b="1" i="0">
+              <a:rPr sz="1500" b="1" i="0">
                 <a:solidFill>
                   <a:srgbClr val="1A1A1A"/>
                 </a:solidFill>
@@ -10676,7 +10699,7 @@
               <a:buChar char="•"/>
             </a:pPr>
             <a:r>
-              <a:rPr sz="1400" b="1" i="0">
+              <a:rPr sz="1350" b="1" i="0">
                 <a:solidFill>
                   <a:srgbClr val="1A1A1A"/>
                 </a:solidFill>
@@ -10686,7 +10709,7 @@
               <a:t>Python·OpenCV</a:t>
             </a:r>
             <a:r>
-              <a:rPr sz="1400" b="0" i="0">
+              <a:rPr sz="1350" b="0" i="0">
                 <a:solidFill>
                   <a:srgbClr val="333333"/>
                 </a:solidFill>
@@ -10696,7 +10719,7 @@
               <a:t>: KLT 영상 이동과 처리시간  /  </a:t>
             </a:r>
             <a:r>
-              <a:rPr sz="1400" b="1" i="0">
+              <a:rPr sz="1350" b="1" i="0">
                 <a:solidFill>
                   <a:srgbClr val="1A1A1A"/>
                 </a:solidFill>
@@ -10706,14 +10729,14 @@
               <a:t>MATLAB</a:t>
             </a:r>
             <a:r>
-              <a:rPr sz="1400" b="0" i="0">
+              <a:rPr sz="1350" b="0" i="0">
                 <a:solidFill>
                   <a:srgbClr val="333333"/>
                 </a:solidFill>
                 <a:latin typeface="Arial"/>
                 <a:ea typeface="MS PGothic"/>
               </a:rPr>
-              <a:t>: EKF·시간 처리·평가</a:t>
+              <a:t>: EKF·시간 처리·평가(동일 환경)</a:t>
             </a:r>
           </a:p>
           <a:p>
@@ -10730,7 +10753,7 @@
               <a:buNone/>
             </a:pPr>
             <a:r>
-              <a:rPr sz="1550" b="1" i="0">
+              <a:rPr sz="1500" b="1" i="0">
                 <a:solidFill>
                   <a:srgbClr val="1A1A1A"/>
                 </a:solidFill>
@@ -10753,7 +10776,7 @@
               <a:buChar char="•"/>
             </a:pPr>
             <a:r>
-              <a:rPr sz="1400" b="0" i="0">
+              <a:rPr sz="1350" b="0" i="0">
                 <a:solidFill>
                   <a:srgbClr val="333333"/>
                 </a:solidFill>
@@ -10776,7 +10799,7 @@
               <a:buChar char="–"/>
             </a:pPr>
             <a:r>
-              <a:rPr sz="1350" b="1" i="0">
+              <a:rPr sz="1300" b="1" i="0">
                 <a:solidFill>
                   <a:srgbClr val="1A1A1A"/>
                 </a:solidFill>
@@ -10786,7 +10809,7 @@
               <a:t>A. 지연 무시</a:t>
             </a:r>
             <a:r>
-              <a:rPr sz="1350" b="0" i="0">
+              <a:rPr sz="1300" b="0" i="0">
                 <a:solidFill>
                   <a:srgbClr val="333333"/>
                 </a:solidFill>
@@ -10809,7 +10832,7 @@
               <a:buChar char="–"/>
             </a:pPr>
             <a:r>
-              <a:rPr sz="1350" b="1" i="0">
+              <a:rPr sz="1300" b="1" i="0">
                 <a:solidFill>
                   <a:srgbClr val="1A1A1A"/>
                 </a:solidFill>
@@ -10819,14 +10842,14 @@
               <a:t>B. 지연 시점 융합</a:t>
             </a:r>
             <a:r>
-              <a:rPr sz="1350" b="0" i="0">
+              <a:rPr sz="1300" b="0" i="0">
                 <a:solidFill>
                   <a:srgbClr val="333333"/>
                 </a:solidFill>
                 <a:latin typeface="Arial"/>
                 <a:ea typeface="MS PGothic"/>
               </a:rPr>
-              <a:t>: PX4 EKF2 방식</a:t>
+              <a:t>: PX4 EKF2 방식 (현재 값은 출력 예측기)</a:t>
             </a:r>
           </a:p>
           <a:p>
@@ -10842,7 +10865,7 @@
               <a:buChar char="–"/>
             </a:pPr>
             <a:r>
-              <a:rPr sz="1350" b="1" i="0">
+              <a:rPr sz="1300" b="1" i="0">
                 <a:solidFill>
                   <a:srgbClr val="1A1A1A"/>
                 </a:solidFill>
@@ -10852,14 +10875,14 @@
               <a:t>C. 과거 상태 재추정</a:t>
             </a:r>
             <a:r>
-              <a:rPr sz="1350" b="0" i="0">
+              <a:rPr sz="1300" b="0" i="0">
                 <a:solidFill>
                   <a:srgbClr val="333333"/>
                 </a:solidFill>
                 <a:latin typeface="Arial"/>
                 <a:ea typeface="MS PGothic"/>
               </a:rPr>
-              <a:t>: 본 연구에서 구현할 방식</a:t>
+              <a:t>: Kim &amp; Ahn, MSF-EKF 방식</a:t>
             </a:r>
           </a:p>
           <a:p>
@@ -10875,17 +10898,17 @@
               <a:buChar char="•"/>
             </a:pPr>
             <a:r>
-              <a:rPr sz="1400" b="0" i="0">
+              <a:rPr sz="1350" b="0" i="0">
                 <a:solidFill>
                   <a:srgbClr val="333333"/>
                 </a:solidFill>
                 <a:latin typeface="Arial"/>
                 <a:ea typeface="MS PGothic"/>
               </a:rPr>
-              <a:t>지표: </a:t>
-            </a:r>
-            <a:r>
-              <a:rPr sz="1400" b="1" i="0">
+              <a:t>현재 시각 추정값 vs 정답: </a:t>
+            </a:r>
+            <a:r>
+              <a:rPr sz="1350" b="1" i="0">
                 <a:solidFill>
                   <a:srgbClr val="1A1A1A"/>
                 </a:solidFill>
@@ -10895,17 +10918,17 @@
               <a:t>ATE</a:t>
             </a:r>
             <a:r>
-              <a:rPr sz="1400" b="0" i="0">
+              <a:rPr sz="1350" b="0" i="0">
                 <a:solidFill>
                   <a:srgbClr val="333333"/>
                 </a:solidFill>
                 <a:latin typeface="Arial"/>
                 <a:ea typeface="MS PGothic"/>
               </a:rPr>
-              <a:t>(위치+yaw 정렬 후 위치 오차), </a:t>
-            </a:r>
-            <a:r>
-              <a:rPr sz="1400" b="1" i="0">
+              <a:t>(전체 궤적), </a:t>
+            </a:r>
+            <a:r>
+              <a:rPr sz="1350" b="1" i="0">
                 <a:solidFill>
                   <a:srgbClr val="1A1A1A"/>
                 </a:solidFill>
@@ -10915,17 +10938,17 @@
               <a:t>RE</a:t>
             </a:r>
             <a:r>
-              <a:rPr sz="1400" b="0" i="0">
+              <a:rPr sz="1350" b="0" i="0">
                 <a:solidFill>
                   <a:srgbClr val="333333"/>
                 </a:solidFill>
                 <a:latin typeface="Arial"/>
                 <a:ea typeface="MS PGothic"/>
               </a:rPr>
-              <a:t>(구간별 상대 오차), </a:t>
-            </a:r>
-            <a:r>
-              <a:rPr sz="1400" b="1" i="0">
+              <a:t>(구간별), </a:t>
+            </a:r>
+            <a:r>
+              <a:rPr sz="1350" b="1" i="0">
                 <a:solidFill>
                   <a:srgbClr val="1A1A1A"/>
                 </a:solidFill>
@@ -10935,7 +10958,7 @@
               <a:t>처리시간</a:t>
             </a:r>
             <a:r>
-              <a:rPr sz="1400" b="0" i="0">
+              <a:rPr sz="1350" b="0" i="0">
                 <a:solidFill>
                   <a:srgbClr val="333333"/>
                 </a:solidFill>
@@ -10958,24 +10981,24 @@
               <a:buChar char="•"/>
             </a:pPr>
             <a:r>
-              <a:rPr sz="1400" b="0" i="0">
+              <a:rPr sz="1350" b="0" i="0">
                 <a:solidFill>
                   <a:srgbClr val="333333"/>
                 </a:solidFill>
                 <a:latin typeface="Arial"/>
                 <a:ea typeface="MS PGothic"/>
               </a:rPr>
-              <a:t>가설: B·C의 정확도는 비슷하고, C는 현재 상태 지연이 없는 대신 </a:t>
-            </a:r>
-            <a:r>
-              <a:rPr sz="1400" b="1" i="0">
+              <a:t>가설: 정확도는 B·C가 비슷, C는 현재 값이 보정 결과와 일치하는 대신 </a:t>
+            </a:r>
+            <a:r>
+              <a:rPr sz="1350" b="1" i="0">
                 <a:solidFill>
                   <a:srgbClr val="1A1A1A"/>
                 </a:solidFill>
                 <a:latin typeface="Arial"/>
                 <a:ea typeface="MS PGothic"/>
               </a:rPr>
-              <a:t>연산이 늘어난다</a:t>
+              <a:t>연산 증가</a:t>
             </a:r>
           </a:p>
         </p:txBody>

</xml_diff>

<commit_message>
v10 final: trim script to fit 5 minutes
Co-Authored-By: Claude Opus 5.5 <noreply@anthropic.com>
Claude-Session: https://claude.ai/code/session_01Qadxmh2cuTPoezLniB2znE
</commit_message>
<xml_diff>
--- a/학생자율연구II_연구계획발표/v10_논문요약형/학생자율연구II_연구계획발표_v10.pptx
+++ b/학생자율연구II_연구계획발표/v10_논문요약형/학생자율연구II_연구계획발표_v10.pptx
@@ -1707,7 +1707,7 @@
           </a:p>
           <a:p>
             <a:r>
-              <a:t>그래서 본 연구는 이 세 센서로 드론의 위치, 속도, 자세를 추정합니다. 다만 수평 위치는 속도를 적분해 구하기 때문에 오차가 쌓일 수 있다는 한계도 함께 봅니다.</a:t>
+              <a:t>그래서 본 연구는 이 세 센서로 드론의 위치, 속도, 자세를 추정합니다. 다만 수평 위치는 오차가 쌓일 수 있다는 한계도 함께 봅니다.</a:t>
             </a:r>
           </a:p>
         </p:txBody>
@@ -1940,7 +1940,7 @@
           </a:p>
           <a:p>
             <a:r>
-              <a:t>드론 분야에는 두 가지 방식이 있습니다. PX4는 필터 자체를 조금 늦은 시점에서 돌리고 현재 값은 따로 예측하고, MSF-EKF는 늦은 측정이 오면 과거로 돌아가 다시 계산합니다.</a:t>
+              <a:t>드론 분야에서는 PX4처럼 필터를 조금 늦은 시점에서 돌리는 방식과, MSF-EKF처럼 과거로 돌아가 다시 계산하는 방식이 쓰입니다.</a:t>
             </a:r>
           </a:p>
           <a:p>
@@ -2386,12 +2386,12 @@
           </a:p>
           <a:p>
             <a:r>
-              <a:t>구현과 평가 계획입니다. 데이터는 공개 드론 데이터셋 INSANE의 실내 구간을 씁니다. 하향 카메라, 거리센서, IMU가 있고, 모션캡처로 측정한 정답 궤적이 있습니다. 카메라 측정마다 촬영 시점에 실제 처리시간과 추가 지연을 더해 도착 시점을 정하고, 데이터를 도착 순서대로 재생해서 실시간처럼 늦게 들어오는 상황을 재현합니다.</a:t>
-            </a:r>
-          </a:p>
-          <a:p>
-            <a:r>
-              <a:t>영상 처리는 파이썬 OpenCV로, 필터와 시간 처리는 매트랩으로 구현합니다. 추가 지연을 0에서 100 ms까지 바꿔 가며, 지연을 무시한 경우, PX4처럼 지연 시점에서 융합한 경우, 과거 상태를 재추정한 경우를 정답 궤적 대비 위치 오차와 처리시간으로 비교하겠습니다. 세 방식 모두 현재 시각의 추정값을 정답과 비교합니다. 예상은 지연 시점에서의 정확도는 B와 C가 비슷하지만, B의 현재 값은 출력 예측기로 따라가는 근사이고 C는 보정 결과 그대로라는 차이가 있으며, 그 대신 C는 다시 계산하는 만큼 연산이 늘어난다는 것입니다. 이 차이를 숫자로 확인하는 것이 목표입니다.</a:t>
+              <a:t>구현과 평가 계획입니다. 데이터는 공개 드론 데이터셋 INSANE의 실내 구간을 씁니다. 하향 카메라, 거리센서, IMU가 있고, 모션캡처로 측정한 정답 궤적이 있습니다. 카메라 측정마다 처리시간과 추가 지연을 더해 도착 시점을 정하고, 도착 순서대로 재생해 실시간 상황을 재현합니다.</a:t>
+            </a:r>
+          </a:p>
+          <a:p>
+            <a:r>
+              <a:t>영상 처리는 파이썬 OpenCV로, 필터와 시간 처리는 매트랩으로 구현합니다. 추가 지연을 0에서 100 ms까지 바꿔 가며, 지연을 무시한 경우, PX4처럼 지연 시점에서 융합한 경우, 과거 상태를 재추정한 경우를 정답 궤적 대비 위치 오차와 처리시간으로 비교하겠습니다. 예상은 정확도는 B와 C가 비슷하고, C는 현재 값이 보정 결과와 일치하는 대신 연산이 늘어난다는 것입니다. 이 차이를 숫자로 확인하겠습니다.</a:t>
             </a:r>
           </a:p>
         </p:txBody>

</xml_diff>